<commit_message>
feat: Integrate Hugging Face Upskill engine for agent trace logging and accuracy evaluation
</commit_message>
<xml_diff>
--- a/output/Presentation.pptx
+++ b/output/Presentation.pptx
@@ -3179,7 +3179,7 @@
               </a:defRPr>
             </a:pPr>
             <a:r>
-              <a:t>Autonomous Multi-Agent Architecture for System Code Analysis &amp; Research Synthesis</a:t>
+              <a:t>AI</a:t>
             </a:r>
           </a:p>
           <a:p>
@@ -3192,7 +3192,7 @@
               </a:defRPr>
             </a:pPr>
             <a:r>
-              <a:t>Generated by Layer 6 Supervisor Engine  |  Critic Score: 92.0/100</a:t>
+              <a:t>Generated by Layer 6 Supervisor Engine  |  Critic Score: 77.0/100</a:t>
             </a:r>
           </a:p>
         </p:txBody>
@@ -3567,7 +3567,7 @@
               </a:defRPr>
             </a:pPr>
             <a:r>
-              <a:t>Analyzed 1 files (34 lines of code).</a:t>
+              <a:t>Analyzed 0 files (0 lines of code).</a:t>
             </a:r>
           </a:p>
           <a:p>
@@ -3580,55 +3580,7 @@
               </a:defRPr>
             </a:pPr>
             <a:r>
-              <a:t>Detected Algorithms: Event-Driven Architecture / Message Bus, Async Concurrent Task Pipeline, Hash Indexing &amp; Lookup</a:t>
-            </a:r>
-          </a:p>
-          <a:p>
-            <a:pPr>
-              <a:defRPr sz="1300">
-                <a:solidFill>
-                  <a:srgbClr val="2C3E50"/>
-                </a:solidFill>
-              </a:defRPr>
-            </a:pPr>
-            <a:r>
-              <a:t>  • main(): Time: O(1), Space: O(1)</a:t>
-            </a:r>
-          </a:p>
-          <a:p>
-            <a:pPr>
-              <a:defRPr sz="1300">
-                <a:solidFill>
-                  <a:srgbClr val="2C3E50"/>
-                </a:solidFill>
-              </a:defRPr>
-            </a:pPr>
-            <a:r>
-              <a:t>  • __init__(): Time: O(1), Space: O(N)</a:t>
-            </a:r>
-          </a:p>
-          <a:p>
-            <a:pPr>
-              <a:defRPr sz="1300">
-                <a:solidFill>
-                  <a:srgbClr val="2C3E50"/>
-                </a:solidFill>
-              </a:defRPr>
-            </a:pPr>
-            <a:r>
-              <a:t>  • subscribe(): Time: O(1), Space: O(N)</a:t>
-            </a:r>
-          </a:p>
-          <a:p>
-            <a:pPr>
-              <a:defRPr sz="1300">
-                <a:solidFill>
-                  <a:srgbClr val="2C3E50"/>
-                </a:solidFill>
-              </a:defRPr>
-            </a:pPr>
-            <a:r>
-              <a:t>  • publish_event(): Time: O(N), Space: O(N)</a:t>
+              <a:t>Detected Algorithms: Modular Pipeline Execution</a:t>
             </a:r>
           </a:p>
         </p:txBody>
@@ -3775,7 +3727,7 @@
               </a:defRPr>
             </a:pPr>
             <a:r>
-              <a:t>✔ Gap 1: Absence of formal verification for 'Event-Driven Architecture / Message Bus' under high-concurrency memory limits.</a:t>
+              <a:t>✔ Gap 1: Absence of formal verification for 'Modular Pipeline Execution' under high-concurrency memory limits.</a:t>
             </a:r>
           </a:p>
           <a:p>
@@ -3952,7 +3904,7 @@
               </a:defRPr>
             </a:pPr>
             <a:r>
-              <a:t>[1] Changxi Zhu, Mehdi Dastani, Shihan Wang, "A Survey of Multi-Agent Deep Reinforcement Learning with Communication," arXiv:2203.08975v2, 2022.</a:t>
+              <a:t>[1] Aoi Naito, Hirokazu Shirado, "Faith in AI can narrow the futures individuals consider," arXiv:2603.28944v2, 2026.</a:t>
             </a:r>
           </a:p>
           <a:p>
@@ -3967,7 +3919,7 @@
               </a:defRPr>
             </a:pPr>
             <a:r>
-              <a:t>[2] F. Bredell, H. A. Engelbrecht, J. C. Schoeman, "Augmenting the action space with conventions to improve multi-agent cooperation in Hanabi," arXiv:2412.06333v3, 2024.</a:t>
+              <a:t>[2] Qingyao Ai, Jingtao Zhan, Yiqun Liu, "Foundations of GenIR," arXiv:2501.02842v1, 2025.</a:t>
             </a:r>
           </a:p>
           <a:p>
@@ -3982,7 +3934,7 @@
               </a:defRPr>
             </a:pPr>
             <a:r>
-              <a:t>[3] Muhammad Haseeb, "Context Engineering for Multi-Agent LLM Code Assistants Using Elicit, NotebookLM, ChatGPT, and Claude Code," arXiv:2508.08322v1, 2025.</a:t>
+              <a:t>[3] Melissa Wilfley, Mengting Ai, Madelyn Rose Sanfilippo, "Competing Visions of Ethical AI: A Case Study of OpenAI," arXiv:2601.16513v1, 2026.</a:t>
             </a:r>
           </a:p>
           <a:p>
@@ -3997,7 +3949,7 @@
               </a:defRPr>
             </a:pPr>
             <a:r>
-              <a:t>[4] Andrés Holgado-Sánchez, Holger Billhardt, Alberto Fernández et al., "Learning the Value Systems of Agents with Preference-based and Inverse Reinforcement Learning," arXiv:2602.04518v1, 2026.</a:t>
+              <a:t>[4] Gerardo Adesso, "Towards The Ultimate Brain: Exploring Scientific Discovery with ChatGPT AI," arXiv:2308.12400v1, 2023.</a:t>
             </a:r>
           </a:p>
         </p:txBody>

</xml_diff>

<commit_message>
test: Run full E2E verification audit and verify 27-agent flow
</commit_message>
<xml_diff>
--- a/output/Presentation.pptx
+++ b/output/Presentation.pptx
@@ -3179,7 +3179,7 @@
               </a:defRPr>
             </a:pPr>
             <a:r>
-              <a:t>AI</a:t>
+              <a:t>High-Performance Multi-Agent Event-Driven Systems</a:t>
             </a:r>
           </a:p>
           <a:p>
@@ -3192,7 +3192,7 @@
               </a:defRPr>
             </a:pPr>
             <a:r>
-              <a:t>Generated by Layer 6 Supervisor Engine  |  Critic Score: 77.0/100</a:t>
+              <a:t>Generated by Layer 6 Supervisor Engine  |  Critic Score: 92.0/100</a:t>
             </a:r>
           </a:p>
         </p:txBody>
@@ -3567,7 +3567,7 @@
               </a:defRPr>
             </a:pPr>
             <a:r>
-              <a:t>Analyzed 0 files (0 lines of code).</a:t>
+              <a:t>Analyzed 1 files (34 lines of code).</a:t>
             </a:r>
           </a:p>
           <a:p>
@@ -3580,7 +3580,55 @@
               </a:defRPr>
             </a:pPr>
             <a:r>
-              <a:t>Detected Algorithms: Modular Pipeline Execution</a:t>
+              <a:t>Detected Algorithms: Event-Driven Architecture / Message Bus, Async Concurrent Task Pipeline, Hash Indexing &amp; Lookup</a:t>
+            </a:r>
+          </a:p>
+          <a:p>
+            <a:pPr>
+              <a:defRPr sz="1300">
+                <a:solidFill>
+                  <a:srgbClr val="2C3E50"/>
+                </a:solidFill>
+              </a:defRPr>
+            </a:pPr>
+            <a:r>
+              <a:t>  • main(): Time: O(1), Space: O(1)</a:t>
+            </a:r>
+          </a:p>
+          <a:p>
+            <a:pPr>
+              <a:defRPr sz="1300">
+                <a:solidFill>
+                  <a:srgbClr val="2C3E50"/>
+                </a:solidFill>
+              </a:defRPr>
+            </a:pPr>
+            <a:r>
+              <a:t>  • __init__(): Time: O(1), Space: O(N)</a:t>
+            </a:r>
+          </a:p>
+          <a:p>
+            <a:pPr>
+              <a:defRPr sz="1300">
+                <a:solidFill>
+                  <a:srgbClr val="2C3E50"/>
+                </a:solidFill>
+              </a:defRPr>
+            </a:pPr>
+            <a:r>
+              <a:t>  • subscribe(): Time: O(1), Space: O(N)</a:t>
+            </a:r>
+          </a:p>
+          <a:p>
+            <a:pPr>
+              <a:defRPr sz="1300">
+                <a:solidFill>
+                  <a:srgbClr val="2C3E50"/>
+                </a:solidFill>
+              </a:defRPr>
+            </a:pPr>
+            <a:r>
+              <a:t>  • publish_event(): Time: O(N), Space: O(N)</a:t>
             </a:r>
           </a:p>
         </p:txBody>
@@ -3727,7 +3775,7 @@
               </a:defRPr>
             </a:pPr>
             <a:r>
-              <a:t>✔ Gap 1: Absence of formal verification for 'Modular Pipeline Execution' under high-concurrency memory limits.</a:t>
+              <a:t>✔ Gap 1: Absence of formal verification for 'Event-Driven Architecture / Message Bus' under high-concurrency memory limits.</a:t>
             </a:r>
           </a:p>
           <a:p>
@@ -3904,7 +3952,7 @@
               </a:defRPr>
             </a:pPr>
             <a:r>
-              <a:t>[1] Aoi Naito, Hirokazu Shirado, "Faith in AI can narrow the futures individuals consider," arXiv:2603.28944v2, 2026.</a:t>
+              <a:t>[1] Changxi Zhu, Mehdi Dastani, Shihan Wang, "A Survey of Multi-Agent Deep Reinforcement Learning with Communication," arXiv:2203.08975v2, 2022.</a:t>
             </a:r>
           </a:p>
           <a:p>
@@ -3919,7 +3967,7 @@
               </a:defRPr>
             </a:pPr>
             <a:r>
-              <a:t>[2] Qingyao Ai, Jingtao Zhan, Yiqun Liu, "Foundations of GenIR," arXiv:2501.02842v1, 2025.</a:t>
+              <a:t>[2] F. Bredell, H. A. Engelbrecht, J. C. Schoeman, "Augmenting the action space with conventions to improve multi-agent cooperation in Hanabi," arXiv:2412.06333v3, 2024.</a:t>
             </a:r>
           </a:p>
           <a:p>
@@ -3934,7 +3982,7 @@
               </a:defRPr>
             </a:pPr>
             <a:r>
-              <a:t>[3] Melissa Wilfley, Mengting Ai, Madelyn Rose Sanfilippo, "Competing Visions of Ethical AI: A Case Study of OpenAI," arXiv:2601.16513v1, 2026.</a:t>
+              <a:t>[3] Jean-Baptiste Soyez, Gildas Morvan, Daniel Dupont et al., "A Methodology to Engineer and Validate Dynamic Multi-level Multi-agent Based Simulations," arXiv:1311.5108v1, 2013.</a:t>
             </a:r>
           </a:p>
           <a:p>
@@ -3949,7 +3997,7 @@
               </a:defRPr>
             </a:pPr>
             <a:r>
-              <a:t>[4] Gerardo Adesso, "Towards The Ultimate Brain: Exploring Scientific Discovery with ChatGPT AI," arXiv:2308.12400v1, 2023.</a:t>
+              <a:t>[4] Andrés Holgado-Sánchez, Holger Billhardt, Alberto Fernández et al., "Learning the Value Systems of Agents with Preference-based and Inverse Reinforcement Learning," arXiv:2602.04518v1, 2026.</a:t>
             </a:r>
           </a:p>
         </p:txBody>

</xml_diff>

<commit_message>
feat: Implement Hybrid Mamba-Transformer Neural Engine
</commit_message>
<xml_diff>
--- a/output/Presentation.pptx
+++ b/output/Presentation.pptx
@@ -3179,7 +3179,7 @@
               </a:defRPr>
             </a:pPr>
             <a:r>
-              <a:t>High-Performance Multi-Agent Event-Driven Systems</a:t>
+              <a:t>Hybrid Mamba-Transformer Autonomous Systems</a:t>
             </a:r>
           </a:p>
           <a:p>
@@ -3952,7 +3952,7 @@
               </a:defRPr>
             </a:pPr>
             <a:r>
-              <a:t>[1] Changxi Zhu, Mehdi Dastani, Shihan Wang, "A Survey of Multi-Agent Deep Reinforcement Learning with Communication," arXiv:2203.08975v2, 2022.</a:t>
+              <a:t>[1] Leonardo Colombo, Maria Emma Eyrea Irazu, "Symmetries and periodic orbits in simple hybrid Routhian systems," arXiv:2001.08941v1, 2020.</a:t>
             </a:r>
           </a:p>
           <a:p>
@@ -3967,7 +3967,7 @@
               </a:defRPr>
             </a:pPr>
             <a:r>
-              <a:t>[2] F. Bredell, H. A. Engelbrecht, J. C. Schoeman, "Augmenting the action space with conventions to improve multi-agent cooperation in Hanabi," arXiv:2412.06333v3, 2024.</a:t>
+              <a:t>[2] Olena V. Mul, Delfim F. M. Torres, Volodymyr P. Kravchenko, "Dynamics of Controlled Hybrid Systems of Aerial Cable-Ways," arXiv:0607200v1, 2006.</a:t>
             </a:r>
           </a:p>
           <a:p>
@@ -3982,7 +3982,7 @@
               </a:defRPr>
             </a:pPr>
             <a:r>
-              <a:t>[3] Jean-Baptiste Soyez, Gildas Morvan, Daniel Dupont et al., "A Methodology to Engineer and Validate Dynamic Multi-level Multi-agent Based Simulations," arXiv:1311.5108v1, 2013.</a:t>
+              <a:t>[3] Michael Malisoff, Frederic Mazenc, "Constructions of Strict Lyapunov Functions for Discrete Time and Hybrid Time-Varying Systems," arXiv:0610210v1, 2006.</a:t>
             </a:r>
           </a:p>
           <a:p>
@@ -3997,7 +3997,7 @@
               </a:defRPr>
             </a:pPr>
             <a:r>
-              <a:t>[4] Andrés Holgado-Sánchez, Holger Billhardt, Alberto Fernández et al., "Learning the Value Systems of Agents with Preference-based and Inverse Reinforcement Learning," arXiv:2602.04518v1, 2026.</a:t>
+              <a:t>[4] Chinmay Vilas Samak, Tanmay Vilas Samak, Sivanathan Kandhasamy, "Control Strategies for Autonomous Vehicles," arXiv:2011.08729v3, 2020.</a:t>
             </a:r>
           </a:p>
         </p:txBody>

</xml_diff>

<commit_message>
feat: Add Layer 0 Sandbox Profiler, SQLite Database Engine, and Layer 7 Real-Time Web Dashboard
</commit_message>
<xml_diff>
--- a/output/Presentation.pptx
+++ b/output/Presentation.pptx
@@ -3179,7 +3179,7 @@
               </a:defRPr>
             </a:pPr>
             <a:r>
-              <a:t>Hybrid Mamba-Transformer Autonomous Systems</a:t>
+              <a:t>FastAPI Web Dashboard Test</a:t>
             </a:r>
           </a:p>
           <a:p>
@@ -3952,7 +3952,7 @@
               </a:defRPr>
             </a:pPr>
             <a:r>
-              <a:t>[1] Leonardo Colombo, Maria Emma Eyrea Irazu, "Symmetries and periodic orbits in simple hybrid Routhian systems," arXiv:2001.08941v1, 2020.</a:t>
+              <a:t>[1] Alessandro Tundo, Chiara Castelnovo, Marco Mobilio et al., "Declarative Dashboard Generation," arXiv:2101.00274v1, 2021.</a:t>
             </a:r>
           </a:p>
           <a:p>
@@ -3967,7 +3967,7 @@
               </a:defRPr>
             </a:pPr>
             <a:r>
-              <a:t>[2] Olena V. Mul, Delfim F. M. Torres, Volodymyr P. Kravchenko, "Dynamics of Controlled Hybrid Systems of Aerial Cable-Ways," arXiv:0607200v1, 2006.</a:t>
+              <a:t>[2] Gerhard Gossen, Elena Demidova, Thomas Risse, "Analyzing Web Archives Through Topic and Event Focused Sub-collections," arXiv:1612.05413v1, 2016.</a:t>
             </a:r>
           </a:p>
           <a:p>
@@ -3982,7 +3982,7 @@
               </a:defRPr>
             </a:pPr>
             <a:r>
-              <a:t>[3] Michael Malisoff, Frederic Mazenc, "Constructions of Strict Lyapunov Functions for Discrete Time and Hybrid Time-Varying Systems," arXiv:0610210v1, 2006.</a:t>
+              <a:t>[3] Thomas Minier, Hala Skaf-Molli, Pascal Molli, "SaGe: Web Preemption for Public SPARQL Query Services," arXiv:1902.04790v1, 2019.</a:t>
             </a:r>
           </a:p>
           <a:p>
@@ -3997,7 +3997,7 @@
               </a:defRPr>
             </a:pPr>
             <a:r>
-              <a:t>[4] Chinmay Vilas Samak, Tanmay Vilas Samak, Sivanathan Kandhasamy, "Control Strategies for Autonomous Vehicles," arXiv:2011.08729v3, 2020.</a:t>
+              <a:t>[4] Luca Vassio, Idilio Drago, Marco Mellia et al., "You, the Web and Your Device: Longitudinal Characterization of Browsing Habits," arXiv:1806.07158v2, 2018.</a:t>
             </a:r>
           </a:p>
         </p:txBody>

</xml_diff>

<commit_message>
Optimize LLM pipeline and refine autonomous research synthesis
</commit_message>
<xml_diff>
--- a/output/Presentation.pptx
+++ b/output/Presentation.pptx
@@ -3179,7 +3179,7 @@
               </a:defRPr>
             </a:pPr>
             <a:r>
-              <a:t>FastAPI Web Dashboard Test</a:t>
+              <a:t>Python packaging structure</a:t>
             </a:r>
           </a:p>
           <a:p>
@@ -3567,7 +3567,7 @@
               </a:defRPr>
             </a:pPr>
             <a:r>
-              <a:t>Analyzed 1 files (34 lines of code).</a:t>
+              <a:t>Analyzed 5 files (77 lines of code).</a:t>
             </a:r>
           </a:p>
           <a:p>
@@ -3580,7 +3580,7 @@
               </a:defRPr>
             </a:pPr>
             <a:r>
-              <a:t>Detected Algorithms: Event-Driven Architecture / Message Bus, Async Concurrent Task Pipeline, Hash Indexing &amp; Lookup</a:t>
+              <a:t>Detected Algorithms: Modular Pipeline Execution</a:t>
             </a:r>
           </a:p>
           <a:p>
@@ -3592,7 +3592,7 @@
               </a:defRPr>
             </a:pPr>
             <a:r>
-              <a:t>  • main(): Time: O(1), Space: O(1)</a:t>
+              <a:t>  • lint(): Time: O(1), Space: O(1)</a:t>
             </a:r>
           </a:p>
           <a:p>
@@ -3604,7 +3604,7 @@
               </a:defRPr>
             </a:pPr>
             <a:r>
-              <a:t>  • __init__(): Time: O(1), Space: O(N)</a:t>
+              <a:t>  • build_and_check_dists(): Time: O(1), Space: O(1)</a:t>
             </a:r>
           </a:p>
           <a:p>
@@ -3616,7 +3616,7 @@
               </a:defRPr>
             </a:pPr>
             <a:r>
-              <a:t>  • subscribe(): Time: O(1), Space: O(N)</a:t>
+              <a:t>  • tests(): Time: O(1), Space: O(N)</a:t>
             </a:r>
           </a:p>
           <a:p>
@@ -3628,7 +3628,7 @@
               </a:defRPr>
             </a:pPr>
             <a:r>
-              <a:t>  • publish_event(): Time: O(N), Space: O(N)</a:t>
+              <a:t>  • test_add_one(): Time: O(1), Space: O(1)</a:t>
             </a:r>
           </a:p>
         </p:txBody>
@@ -3775,7 +3775,7 @@
               </a:defRPr>
             </a:pPr>
             <a:r>
-              <a:t>✔ Gap 1: Absence of formal verification for 'Event-Driven Architecture / Message Bus' under high-concurrency memory limits.</a:t>
+              <a:t>✔ Gap 1: Absence of formal verification for 'Modular Pipeline Execution' under high-concurrency memory limits.</a:t>
             </a:r>
           </a:p>
           <a:p>
@@ -3952,7 +3952,7 @@
               </a:defRPr>
             </a:pPr>
             <a:r>
-              <a:t>[1] Alessandro Tundo, Chiara Castelnovo, Marco Mobilio et al., "Declarative Dashboard Generation," arXiv:2101.00274v1, 2021.</a:t>
+              <a:t>[1] Dmitri Goldenberg, "Social Network Analysis: From Graph Theory to Applications with Python," arXiv:2102.10014v1, 2021.</a:t>
             </a:r>
           </a:p>
           <a:p>
@@ -3967,7 +3967,7 @@
               </a:defRPr>
             </a:pPr>
             <a:r>
-              <a:t>[2] Gerhard Gossen, Elena Demidova, Thomas Risse, "Analyzing Web Archives Through Topic and Event Focused Sub-collections," arXiv:1612.05413v1, 2016.</a:t>
+              <a:t>[2] Nick Brown, "ePython: An implementation of Python for the many-core Epiphany coprocessor," arXiv:2010.14827v1, 2020.</a:t>
             </a:r>
           </a:p>
           <a:p>
@@ -3982,7 +3982,7 @@
               </a:defRPr>
             </a:pPr>
             <a:r>
-              <a:t>[3] Thomas Minier, Hala Skaf-Molli, Pascal Molli, "SaGe: Web Preemption for Public SPARQL Query Services," arXiv:1902.04790v1, 2019.</a:t>
+              <a:t>[3] Timothy J. Callow, Daniel Kotik, Eli Kraisler et al., "atoMEC: An open-source average-atom Python code," arXiv:2206.01074v2, 2022.</a:t>
             </a:r>
           </a:p>
           <a:p>
@@ -3997,7 +3997,7 @@
               </a:defRPr>
             </a:pPr>
             <a:r>
-              <a:t>[4] Luca Vassio, Idilio Drago, Marco Mellia et al., "You, the Web and Your Device: Longitudinal Characterization of Browsing Habits," arXiv:1806.07158v2, 2018.</a:t>
+              <a:t>[4] S. Farrens, A. Grigis, L. El Gueddari et al., "PySAP: Python Sparse Data Analysis Package for Multidisciplinary Image Processing," arXiv:1910.08465v2, 2019.</a:t>
             </a:r>
           </a:p>
         </p:txBody>

</xml_diff>